<commit_message>
Update Shikayat.pptx with new content
</commit_message>
<xml_diff>
--- a/docs/Shikayat.pptx
+++ b/docs/Shikayat.pptx
@@ -5,15 +5,15 @@
     <p:sldMasterId id="2147483648" r:id="rId1"/>
   </p:sldMasterIdLst>
   <p:sldIdLst>
-    <p:sldId id="256" r:id="rId7"/>
-    <p:sldId id="257" r:id="rId8"/>
-    <p:sldId id="258" r:id="rId9"/>
-    <p:sldId id="259" r:id="rId10"/>
-    <p:sldId id="260" r:id="rId11"/>
-    <p:sldId id="261" r:id="rId12"/>
-    <p:sldId id="262" r:id="rId13"/>
+    <p:sldId id="256" r:id="rId2"/>
+    <p:sldId id="257" r:id="rId3"/>
+    <p:sldId id="258" r:id="rId4"/>
+    <p:sldId id="259" r:id="rId5"/>
+    <p:sldId id="260" r:id="rId6"/>
+    <p:sldId id="261" r:id="rId7"/>
+    <p:sldId id="262" r:id="rId8"/>
   </p:sldIdLst>
-  <p:sldSz cx="12191695" cy="6858000" type="screen4x3"/>
+  <p:sldSz cx="12192000" cy="6858000"/>
   <p:notesSz cx="6858000" cy="9144000"/>
   <p:defaultTextStyle>
     <a:defPPr>
@@ -110,6 +110,22 @@
       </a:defRPr>
     </a:lvl9pPr>
   </p:defaultTextStyle>
+  <p:extLst>
+    <p:ext uri="{EFAFB233-063F-42B5-8137-9DF3F51BA10A}">
+      <p15:sldGuideLst xmlns:p15="http://schemas.microsoft.com/office/powerpoint/2012/main">
+        <p15:guide id="1" orient="horz" pos="2160">
+          <p15:clr>
+            <a:srgbClr val="A4A3A4"/>
+          </p15:clr>
+        </p15:guide>
+        <p15:guide id="2" pos="2880">
+          <p15:clr>
+            <a:srgbClr val="A4A3A4"/>
+          </p15:clr>
+        </p15:guide>
+      </p15:sldGuideLst>
+    </p:ext>
+  </p:extLst>
 </p:presentation>
 </file>
 
@@ -151,10 +167,9 @@
           <a:lstStyle/>
           <a:p>
             <a:r>
-              <a:rPr lang="en-US" smtClean="0"/>
+              <a:rPr lang="en-US"/>
               <a:t>Click to edit Master title style</a:t>
             </a:r>
-            <a:endParaRPr lang="en-US"/>
           </a:p>
         </p:txBody>
       </p:sp>
@@ -270,10 +285,9 @@
           </a:lstStyle>
           <a:p>
             <a:r>
-              <a:rPr lang="en-US" smtClean="0"/>
+              <a:rPr lang="en-US"/>
               <a:t>Click to edit Master subtitle style</a:t>
             </a:r>
-            <a:endParaRPr lang="en-US"/>
           </a:p>
         </p:txBody>
       </p:sp>
@@ -294,7 +308,7 @@
           <a:p>
             <a:fld id="{5BCAD085-E8A6-8845-BD4E-CB4CCA059FC4}" type="datetimeFigureOut">
               <a:rPr lang="en-US" smtClean="0"/>
-              <a:t>1/27/13</a:t>
+              <a:t>10/10/2026</a:t>
             </a:fld>
             <a:endParaRPr lang="en-US"/>
           </a:p>
@@ -388,10 +402,9 @@
           <a:lstStyle/>
           <a:p>
             <a:r>
-              <a:rPr lang="en-US" smtClean="0"/>
+              <a:rPr lang="en-US"/>
               <a:t>Click to edit Master title style</a:t>
             </a:r>
-            <a:endParaRPr lang="en-US"/>
           </a:p>
         </p:txBody>
       </p:sp>
@@ -412,38 +425,37 @@
           <a:p>
             <a:pPr lvl="0"/>
             <a:r>
-              <a:rPr lang="en-US" smtClean="0"/>
+              <a:rPr lang="en-US"/>
               <a:t>Click to edit Master text styles</a:t>
             </a:r>
           </a:p>
           <a:p>
             <a:pPr lvl="1"/>
             <a:r>
-              <a:rPr lang="en-US" smtClean="0"/>
+              <a:rPr lang="en-US"/>
               <a:t>Second level</a:t>
             </a:r>
           </a:p>
           <a:p>
             <a:pPr lvl="2"/>
             <a:r>
-              <a:rPr lang="en-US" smtClean="0"/>
+              <a:rPr lang="en-US"/>
               <a:t>Third level</a:t>
             </a:r>
           </a:p>
           <a:p>
             <a:pPr lvl="3"/>
             <a:r>
-              <a:rPr lang="en-US" smtClean="0"/>
+              <a:rPr lang="en-US"/>
               <a:t>Fourth level</a:t>
             </a:r>
           </a:p>
           <a:p>
             <a:pPr lvl="4"/>
             <a:r>
-              <a:rPr lang="en-US" smtClean="0"/>
+              <a:rPr lang="en-US"/>
               <a:t>Fifth level</a:t>
             </a:r>
-            <a:endParaRPr lang="en-US"/>
           </a:p>
         </p:txBody>
       </p:sp>
@@ -464,7 +476,7 @@
           <a:p>
             <a:fld id="{5BCAD085-E8A6-8845-BD4E-CB4CCA059FC4}" type="datetimeFigureOut">
               <a:rPr lang="en-US" smtClean="0"/>
-              <a:t>1/27/13</a:t>
+              <a:t>10/10/2026</a:t>
             </a:fld>
             <a:endParaRPr lang="en-US"/>
           </a:p>
@@ -563,10 +575,9 @@
           <a:lstStyle/>
           <a:p>
             <a:r>
-              <a:rPr lang="en-US" smtClean="0"/>
+              <a:rPr lang="en-US"/>
               <a:t>Click to edit Master title style</a:t>
             </a:r>
-            <a:endParaRPr lang="en-US"/>
           </a:p>
         </p:txBody>
       </p:sp>
@@ -592,38 +603,37 @@
           <a:p>
             <a:pPr lvl="0"/>
             <a:r>
-              <a:rPr lang="en-US" smtClean="0"/>
+              <a:rPr lang="en-US"/>
               <a:t>Click to edit Master text styles</a:t>
             </a:r>
           </a:p>
           <a:p>
             <a:pPr lvl="1"/>
             <a:r>
-              <a:rPr lang="en-US" smtClean="0"/>
+              <a:rPr lang="en-US"/>
               <a:t>Second level</a:t>
             </a:r>
           </a:p>
           <a:p>
             <a:pPr lvl="2"/>
             <a:r>
-              <a:rPr lang="en-US" smtClean="0"/>
+              <a:rPr lang="en-US"/>
               <a:t>Third level</a:t>
             </a:r>
           </a:p>
           <a:p>
             <a:pPr lvl="3"/>
             <a:r>
-              <a:rPr lang="en-US" smtClean="0"/>
+              <a:rPr lang="en-US"/>
               <a:t>Fourth level</a:t>
             </a:r>
           </a:p>
           <a:p>
             <a:pPr lvl="4"/>
             <a:r>
-              <a:rPr lang="en-US" smtClean="0"/>
+              <a:rPr lang="en-US"/>
               <a:t>Fifth level</a:t>
             </a:r>
-            <a:endParaRPr lang="en-US"/>
           </a:p>
         </p:txBody>
       </p:sp>
@@ -644,7 +654,7 @@
           <a:p>
             <a:fld id="{5BCAD085-E8A6-8845-BD4E-CB4CCA059FC4}" type="datetimeFigureOut">
               <a:rPr lang="en-US" smtClean="0"/>
-              <a:t>1/27/13</a:t>
+              <a:t>10/10/2026</a:t>
             </a:fld>
             <a:endParaRPr lang="en-US"/>
           </a:p>
@@ -738,10 +748,9 @@
           <a:lstStyle/>
           <a:p>
             <a:r>
-              <a:rPr lang="en-US" smtClean="0"/>
+              <a:rPr lang="en-US"/>
               <a:t>Click to edit Master title style</a:t>
             </a:r>
-            <a:endParaRPr lang="en-US"/>
           </a:p>
         </p:txBody>
       </p:sp>
@@ -762,38 +771,37 @@
           <a:p>
             <a:pPr lvl="0"/>
             <a:r>
-              <a:rPr lang="en-US" smtClean="0"/>
+              <a:rPr lang="en-US"/>
               <a:t>Click to edit Master text styles</a:t>
             </a:r>
           </a:p>
           <a:p>
             <a:pPr lvl="1"/>
             <a:r>
-              <a:rPr lang="en-US" smtClean="0"/>
+              <a:rPr lang="en-US"/>
               <a:t>Second level</a:t>
             </a:r>
           </a:p>
           <a:p>
             <a:pPr lvl="2"/>
             <a:r>
-              <a:rPr lang="en-US" smtClean="0"/>
+              <a:rPr lang="en-US"/>
               <a:t>Third level</a:t>
             </a:r>
           </a:p>
           <a:p>
             <a:pPr lvl="3"/>
             <a:r>
-              <a:rPr lang="en-US" smtClean="0"/>
+              <a:rPr lang="en-US"/>
               <a:t>Fourth level</a:t>
             </a:r>
           </a:p>
           <a:p>
             <a:pPr lvl="4"/>
             <a:r>
-              <a:rPr lang="en-US" smtClean="0"/>
+              <a:rPr lang="en-US"/>
               <a:t>Fifth level</a:t>
             </a:r>
-            <a:endParaRPr lang="en-US"/>
           </a:p>
         </p:txBody>
       </p:sp>
@@ -814,7 +822,7 @@
           <a:p>
             <a:fld id="{5BCAD085-E8A6-8845-BD4E-CB4CCA059FC4}" type="datetimeFigureOut">
               <a:rPr lang="en-US" smtClean="0"/>
-              <a:t>1/27/13</a:t>
+              <a:t>10/10/2026</a:t>
             </a:fld>
             <a:endParaRPr lang="en-US"/>
           </a:p>
@@ -917,10 +925,9 @@
           </a:lstStyle>
           <a:p>
             <a:r>
-              <a:rPr lang="en-US" smtClean="0"/>
+              <a:rPr lang="en-US"/>
               <a:t>Click to edit Master title style</a:t>
             </a:r>
-            <a:endParaRPr lang="en-US"/>
           </a:p>
         </p:txBody>
       </p:sp>
@@ -1037,7 +1044,7 @@
           <a:p>
             <a:pPr lvl="0"/>
             <a:r>
-              <a:rPr lang="en-US" smtClean="0"/>
+              <a:rPr lang="en-US"/>
               <a:t>Click to edit Master text styles</a:t>
             </a:r>
           </a:p>
@@ -1060,7 +1067,7 @@
           <a:p>
             <a:fld id="{5BCAD085-E8A6-8845-BD4E-CB4CCA059FC4}" type="datetimeFigureOut">
               <a:rPr lang="en-US" smtClean="0"/>
-              <a:t>1/27/13</a:t>
+              <a:t>10/10/2026</a:t>
             </a:fld>
             <a:endParaRPr lang="en-US"/>
           </a:p>
@@ -1154,10 +1161,9 @@
           <a:lstStyle/>
           <a:p>
             <a:r>
-              <a:rPr lang="en-US" smtClean="0"/>
+              <a:rPr lang="en-US"/>
               <a:t>Click to edit Master title style</a:t>
             </a:r>
-            <a:endParaRPr lang="en-US"/>
           </a:p>
         </p:txBody>
       </p:sp>
@@ -1211,38 +1217,37 @@
           <a:p>
             <a:pPr lvl="0"/>
             <a:r>
-              <a:rPr lang="en-US" smtClean="0"/>
+              <a:rPr lang="en-US"/>
               <a:t>Click to edit Master text styles</a:t>
             </a:r>
           </a:p>
           <a:p>
             <a:pPr lvl="1"/>
             <a:r>
-              <a:rPr lang="en-US" smtClean="0"/>
+              <a:rPr lang="en-US"/>
               <a:t>Second level</a:t>
             </a:r>
           </a:p>
           <a:p>
             <a:pPr lvl="2"/>
             <a:r>
-              <a:rPr lang="en-US" smtClean="0"/>
+              <a:rPr lang="en-US"/>
               <a:t>Third level</a:t>
             </a:r>
           </a:p>
           <a:p>
             <a:pPr lvl="3"/>
             <a:r>
-              <a:rPr lang="en-US" smtClean="0"/>
+              <a:rPr lang="en-US"/>
               <a:t>Fourth level</a:t>
             </a:r>
           </a:p>
           <a:p>
             <a:pPr lvl="4"/>
             <a:r>
-              <a:rPr lang="en-US" smtClean="0"/>
+              <a:rPr lang="en-US"/>
               <a:t>Fifth level</a:t>
             </a:r>
-            <a:endParaRPr lang="en-US"/>
           </a:p>
         </p:txBody>
       </p:sp>
@@ -1296,38 +1301,37 @@
           <a:p>
             <a:pPr lvl="0"/>
             <a:r>
-              <a:rPr lang="en-US" smtClean="0"/>
+              <a:rPr lang="en-US"/>
               <a:t>Click to edit Master text styles</a:t>
             </a:r>
           </a:p>
           <a:p>
             <a:pPr lvl="1"/>
             <a:r>
-              <a:rPr lang="en-US" smtClean="0"/>
+              <a:rPr lang="en-US"/>
               <a:t>Second level</a:t>
             </a:r>
           </a:p>
           <a:p>
             <a:pPr lvl="2"/>
             <a:r>
-              <a:rPr lang="en-US" smtClean="0"/>
+              <a:rPr lang="en-US"/>
               <a:t>Third level</a:t>
             </a:r>
           </a:p>
           <a:p>
             <a:pPr lvl="3"/>
             <a:r>
-              <a:rPr lang="en-US" smtClean="0"/>
+              <a:rPr lang="en-US"/>
               <a:t>Fourth level</a:t>
             </a:r>
           </a:p>
           <a:p>
             <a:pPr lvl="4"/>
             <a:r>
-              <a:rPr lang="en-US" smtClean="0"/>
+              <a:rPr lang="en-US"/>
               <a:t>Fifth level</a:t>
             </a:r>
-            <a:endParaRPr lang="en-US"/>
           </a:p>
         </p:txBody>
       </p:sp>
@@ -1348,7 +1352,7 @@
           <a:p>
             <a:fld id="{5BCAD085-E8A6-8845-BD4E-CB4CCA059FC4}" type="datetimeFigureOut">
               <a:rPr lang="en-US" smtClean="0"/>
-              <a:t>1/27/13</a:t>
+              <a:t>10/10/2026</a:t>
             </a:fld>
             <a:endParaRPr lang="en-US"/>
           </a:p>
@@ -1446,10 +1450,9 @@
           </a:lstStyle>
           <a:p>
             <a:r>
-              <a:rPr lang="en-US" smtClean="0"/>
+              <a:rPr lang="en-US"/>
               <a:t>Click to edit Master title style</a:t>
             </a:r>
-            <a:endParaRPr lang="en-US"/>
           </a:p>
         </p:txBody>
       </p:sp>
@@ -1512,7 +1515,7 @@
           <a:p>
             <a:pPr lvl="0"/>
             <a:r>
-              <a:rPr lang="en-US" smtClean="0"/>
+              <a:rPr lang="en-US"/>
               <a:t>Click to edit Master text styles</a:t>
             </a:r>
           </a:p>
@@ -1568,38 +1571,37 @@
           <a:p>
             <a:pPr lvl="0"/>
             <a:r>
-              <a:rPr lang="en-US" smtClean="0"/>
+              <a:rPr lang="en-US"/>
               <a:t>Click to edit Master text styles</a:t>
             </a:r>
           </a:p>
           <a:p>
             <a:pPr lvl="1"/>
             <a:r>
-              <a:rPr lang="en-US" smtClean="0"/>
+              <a:rPr lang="en-US"/>
               <a:t>Second level</a:t>
             </a:r>
           </a:p>
           <a:p>
             <a:pPr lvl="2"/>
             <a:r>
-              <a:rPr lang="en-US" smtClean="0"/>
+              <a:rPr lang="en-US"/>
               <a:t>Third level</a:t>
             </a:r>
           </a:p>
           <a:p>
             <a:pPr lvl="3"/>
             <a:r>
-              <a:rPr lang="en-US" smtClean="0"/>
+              <a:rPr lang="en-US"/>
               <a:t>Fourth level</a:t>
             </a:r>
           </a:p>
           <a:p>
             <a:pPr lvl="4"/>
             <a:r>
-              <a:rPr lang="en-US" smtClean="0"/>
+              <a:rPr lang="en-US"/>
               <a:t>Fifth level</a:t>
             </a:r>
-            <a:endParaRPr lang="en-US"/>
           </a:p>
         </p:txBody>
       </p:sp>
@@ -1662,7 +1664,7 @@
           <a:p>
             <a:pPr lvl="0"/>
             <a:r>
-              <a:rPr lang="en-US" smtClean="0"/>
+              <a:rPr lang="en-US"/>
               <a:t>Click to edit Master text styles</a:t>
             </a:r>
           </a:p>
@@ -1718,38 +1720,37 @@
           <a:p>
             <a:pPr lvl="0"/>
             <a:r>
-              <a:rPr lang="en-US" smtClean="0"/>
+              <a:rPr lang="en-US"/>
               <a:t>Click to edit Master text styles</a:t>
             </a:r>
           </a:p>
           <a:p>
             <a:pPr lvl="1"/>
             <a:r>
-              <a:rPr lang="en-US" smtClean="0"/>
+              <a:rPr lang="en-US"/>
               <a:t>Second level</a:t>
             </a:r>
           </a:p>
           <a:p>
             <a:pPr lvl="2"/>
             <a:r>
-              <a:rPr lang="en-US" smtClean="0"/>
+              <a:rPr lang="en-US"/>
               <a:t>Third level</a:t>
             </a:r>
           </a:p>
           <a:p>
             <a:pPr lvl="3"/>
             <a:r>
-              <a:rPr lang="en-US" smtClean="0"/>
+              <a:rPr lang="en-US"/>
               <a:t>Fourth level</a:t>
             </a:r>
           </a:p>
           <a:p>
             <a:pPr lvl="4"/>
             <a:r>
-              <a:rPr lang="en-US" smtClean="0"/>
+              <a:rPr lang="en-US"/>
               <a:t>Fifth level</a:t>
             </a:r>
-            <a:endParaRPr lang="en-US"/>
           </a:p>
         </p:txBody>
       </p:sp>
@@ -1770,7 +1771,7 @@
           <a:p>
             <a:fld id="{5BCAD085-E8A6-8845-BD4E-CB4CCA059FC4}" type="datetimeFigureOut">
               <a:rPr lang="en-US" smtClean="0"/>
-              <a:t>1/27/13</a:t>
+              <a:t>10/10/2026</a:t>
             </a:fld>
             <a:endParaRPr lang="en-US"/>
           </a:p>
@@ -1864,10 +1865,9 @@
           <a:lstStyle/>
           <a:p>
             <a:r>
-              <a:rPr lang="en-US" smtClean="0"/>
+              <a:rPr lang="en-US"/>
               <a:t>Click to edit Master title style</a:t>
             </a:r>
-            <a:endParaRPr lang="en-US"/>
           </a:p>
         </p:txBody>
       </p:sp>
@@ -1888,7 +1888,7 @@
           <a:p>
             <a:fld id="{5BCAD085-E8A6-8845-BD4E-CB4CCA059FC4}" type="datetimeFigureOut">
               <a:rPr lang="en-US" smtClean="0"/>
-              <a:t>1/27/13</a:t>
+              <a:t>10/10/2026</a:t>
             </a:fld>
             <a:endParaRPr lang="en-US"/>
           </a:p>
@@ -1983,7 +1983,7 @@
           <a:p>
             <a:fld id="{5BCAD085-E8A6-8845-BD4E-CB4CCA059FC4}" type="datetimeFigureOut">
               <a:rPr lang="en-US" smtClean="0"/>
-              <a:t>1/27/13</a:t>
+              <a:t>10/10/2026</a:t>
             </a:fld>
             <a:endParaRPr lang="en-US"/>
           </a:p>
@@ -2086,10 +2086,9 @@
           </a:lstStyle>
           <a:p>
             <a:r>
-              <a:rPr lang="en-US" smtClean="0"/>
+              <a:rPr lang="en-US"/>
               <a:t>Click to edit Master title style</a:t>
             </a:r>
-            <a:endParaRPr lang="en-US"/>
           </a:p>
         </p:txBody>
       </p:sp>
@@ -2143,38 +2142,37 @@
           <a:p>
             <a:pPr lvl="0"/>
             <a:r>
-              <a:rPr lang="en-US" smtClean="0"/>
+              <a:rPr lang="en-US"/>
               <a:t>Click to edit Master text styles</a:t>
             </a:r>
           </a:p>
           <a:p>
             <a:pPr lvl="1"/>
             <a:r>
-              <a:rPr lang="en-US" smtClean="0"/>
+              <a:rPr lang="en-US"/>
               <a:t>Second level</a:t>
             </a:r>
           </a:p>
           <a:p>
             <a:pPr lvl="2"/>
             <a:r>
-              <a:rPr lang="en-US" smtClean="0"/>
+              <a:rPr lang="en-US"/>
               <a:t>Third level</a:t>
             </a:r>
           </a:p>
           <a:p>
             <a:pPr lvl="3"/>
             <a:r>
-              <a:rPr lang="en-US" smtClean="0"/>
+              <a:rPr lang="en-US"/>
               <a:t>Fourth level</a:t>
             </a:r>
           </a:p>
           <a:p>
             <a:pPr lvl="4"/>
             <a:r>
-              <a:rPr lang="en-US" smtClean="0"/>
+              <a:rPr lang="en-US"/>
               <a:t>Fifth level</a:t>
             </a:r>
-            <a:endParaRPr lang="en-US"/>
           </a:p>
         </p:txBody>
       </p:sp>
@@ -2237,7 +2235,7 @@
           <a:p>
             <a:pPr lvl="0"/>
             <a:r>
-              <a:rPr lang="en-US" smtClean="0"/>
+              <a:rPr lang="en-US"/>
               <a:t>Click to edit Master text styles</a:t>
             </a:r>
           </a:p>
@@ -2260,7 +2258,7 @@
           <a:p>
             <a:fld id="{5BCAD085-E8A6-8845-BD4E-CB4CCA059FC4}" type="datetimeFigureOut">
               <a:rPr lang="en-US" smtClean="0"/>
-              <a:t>1/27/13</a:t>
+              <a:t>10/10/2026</a:t>
             </a:fld>
             <a:endParaRPr lang="en-US"/>
           </a:p>
@@ -2363,10 +2361,9 @@
           </a:lstStyle>
           <a:p>
             <a:r>
-              <a:rPr lang="en-US" smtClean="0"/>
+              <a:rPr lang="en-US"/>
               <a:t>Click to edit Master title style</a:t>
             </a:r>
-            <a:endParaRPr lang="en-US"/>
           </a:p>
         </p:txBody>
       </p:sp>
@@ -2490,7 +2487,7 @@
           <a:p>
             <a:pPr lvl="0"/>
             <a:r>
-              <a:rPr lang="en-US" smtClean="0"/>
+              <a:rPr lang="en-US"/>
               <a:t>Click to edit Master text styles</a:t>
             </a:r>
           </a:p>
@@ -2513,7 +2510,7 @@
           <a:p>
             <a:fld id="{5BCAD085-E8A6-8845-BD4E-CB4CCA059FC4}" type="datetimeFigureOut">
               <a:rPr lang="en-US" smtClean="0"/>
-              <a:t>1/27/13</a:t>
+              <a:t>10/10/2026</a:t>
             </a:fld>
             <a:endParaRPr lang="en-US"/>
           </a:p>
@@ -2622,10 +2619,9 @@
           <a:lstStyle/>
           <a:p>
             <a:r>
-              <a:rPr lang="en-US" smtClean="0"/>
+              <a:rPr lang="en-US"/>
               <a:t>Click to edit Master title style</a:t>
             </a:r>
-            <a:endParaRPr lang="en-US"/>
           </a:p>
         </p:txBody>
       </p:sp>
@@ -2656,38 +2652,37 @@
           <a:p>
             <a:pPr lvl="0"/>
             <a:r>
-              <a:rPr lang="en-US" smtClean="0"/>
+              <a:rPr lang="en-US"/>
               <a:t>Click to edit Master text styles</a:t>
             </a:r>
           </a:p>
           <a:p>
             <a:pPr lvl="1"/>
             <a:r>
-              <a:rPr lang="en-US" smtClean="0"/>
+              <a:rPr lang="en-US"/>
               <a:t>Second level</a:t>
             </a:r>
           </a:p>
           <a:p>
             <a:pPr lvl="2"/>
             <a:r>
-              <a:rPr lang="en-US" smtClean="0"/>
+              <a:rPr lang="en-US"/>
               <a:t>Third level</a:t>
             </a:r>
           </a:p>
           <a:p>
             <a:pPr lvl="3"/>
             <a:r>
-              <a:rPr lang="en-US" smtClean="0"/>
+              <a:rPr lang="en-US"/>
               <a:t>Fourth level</a:t>
             </a:r>
           </a:p>
           <a:p>
             <a:pPr lvl="4"/>
             <a:r>
-              <a:rPr lang="en-US" smtClean="0"/>
+              <a:rPr lang="en-US"/>
               <a:t>Fifth level</a:t>
             </a:r>
-            <a:endParaRPr lang="en-US"/>
           </a:p>
         </p:txBody>
       </p:sp>
@@ -2726,7 +2721,7 @@
           <a:p>
             <a:fld id="{5BCAD085-E8A6-8845-BD4E-CB4CCA059FC4}" type="datetimeFigureOut">
               <a:rPr lang="en-US" smtClean="0"/>
-              <a:t>1/27/13</a:t>
+              <a:t>10/10/2026</a:t>
             </a:fld>
             <a:endParaRPr lang="en-US"/>
           </a:p>
@@ -3085,7 +3080,7 @@
 </file>
 
 <file path=ppt/slides/slide1.xml><?xml version="1.0" encoding="utf-8"?>
-<p:sld xmlns:a="http://schemas.openxmlformats.org/drawingml/2006/main" xmlns:p="http://schemas.openxmlformats.org/presentationml/2006/main" xmlns:r="http://schemas.openxmlformats.org/officeDocument/2006/relationships">
+<p:sld xmlns:a="http://schemas.openxmlformats.org/drawingml/2006/main" xmlns:r="http://schemas.openxmlformats.org/officeDocument/2006/relationships" xmlns:p="http://schemas.openxmlformats.org/presentationml/2006/main">
   <p:cSld>
     <p:spTree>
       <p:nvGrpSpPr>
@@ -3093,7 +3088,14 @@
         <p:cNvGrpSpPr/>
         <p:nvPr/>
       </p:nvGrpSpPr>
-      <p:grpSpPr/>
+      <p:grpSpPr>
+        <a:xfrm>
+          <a:off x="0" y="0"/>
+          <a:ext cx="0" cy="0"/>
+          <a:chOff x="0" y="0"/>
+          <a:chExt cx="0" cy="0"/>
+        </a:xfrm>
+      </p:grpSpPr>
       <p:sp>
         <p:nvSpPr>
           <p:cNvPr id="2" name="Rectangle 1"/>
@@ -3135,6 +3137,7 @@
           <a:lstStyle/>
           <a:p>
             <a:pPr algn="ctr"/>
+            <a:endParaRPr/>
           </a:p>
         </p:txBody>
       </p:sp>
@@ -3179,6 +3182,7 @@
           <a:lstStyle/>
           <a:p>
             <a:pPr algn="ctr"/>
+            <a:endParaRPr/>
           </a:p>
         </p:txBody>
       </p:sp>
@@ -3364,7 +3368,7 @@
 </file>
 
 <file path=ppt/slides/slide2.xml><?xml version="1.0" encoding="utf-8"?>
-<p:sld xmlns:a="http://schemas.openxmlformats.org/drawingml/2006/main" xmlns:p="http://schemas.openxmlformats.org/presentationml/2006/main" xmlns:r="http://schemas.openxmlformats.org/officeDocument/2006/relationships">
+<p:sld xmlns:a="http://schemas.openxmlformats.org/drawingml/2006/main" xmlns:r="http://schemas.openxmlformats.org/officeDocument/2006/relationships" xmlns:p="http://schemas.openxmlformats.org/presentationml/2006/main">
   <p:cSld>
     <p:spTree>
       <p:nvGrpSpPr>
@@ -3372,7 +3376,14 @@
         <p:cNvGrpSpPr/>
         <p:nvPr/>
       </p:nvGrpSpPr>
-      <p:grpSpPr/>
+      <p:grpSpPr>
+        <a:xfrm>
+          <a:off x="0" y="0"/>
+          <a:ext cx="0" cy="0"/>
+          <a:chOff x="0" y="0"/>
+          <a:chExt cx="0" cy="0"/>
+        </a:xfrm>
+      </p:grpSpPr>
       <p:sp>
         <p:nvSpPr>
           <p:cNvPr id="2" name="Rectangle 1"/>
@@ -3414,6 +3425,7 @@
           <a:lstStyle/>
           <a:p>
             <a:pPr algn="ctr"/>
+            <a:endParaRPr/>
           </a:p>
         </p:txBody>
       </p:sp>
@@ -3536,6 +3548,7 @@
           <a:lstStyle/>
           <a:p>
             <a:pPr algn="ctr"/>
+            <a:endParaRPr/>
           </a:p>
         </p:txBody>
       </p:sp>
@@ -3692,6 +3705,7 @@
           <a:lstStyle/>
           <a:p>
             <a:pPr algn="ctr"/>
+            <a:endParaRPr/>
           </a:p>
         </p:txBody>
       </p:sp>
@@ -3743,7 +3757,7 @@
 </file>
 
 <file path=ppt/slides/slide3.xml><?xml version="1.0" encoding="utf-8"?>
-<p:sld xmlns:a="http://schemas.openxmlformats.org/drawingml/2006/main" xmlns:p="http://schemas.openxmlformats.org/presentationml/2006/main" xmlns:r="http://schemas.openxmlformats.org/officeDocument/2006/relationships">
+<p:sld xmlns:a="http://schemas.openxmlformats.org/drawingml/2006/main" xmlns:r="http://schemas.openxmlformats.org/officeDocument/2006/relationships" xmlns:p="http://schemas.openxmlformats.org/presentationml/2006/main">
   <p:cSld>
     <p:spTree>
       <p:nvGrpSpPr>
@@ -3751,7 +3765,14 @@
         <p:cNvGrpSpPr/>
         <p:nvPr/>
       </p:nvGrpSpPr>
-      <p:grpSpPr/>
+      <p:grpSpPr>
+        <a:xfrm>
+          <a:off x="0" y="0"/>
+          <a:ext cx="0" cy="0"/>
+          <a:chOff x="0" y="0"/>
+          <a:chExt cx="0" cy="0"/>
+        </a:xfrm>
+      </p:grpSpPr>
       <p:sp>
         <p:nvSpPr>
           <p:cNvPr id="2" name="Rectangle 1"/>
@@ -3760,7 +3781,7 @@
         </p:nvSpPr>
         <p:spPr>
           <a:xfrm>
-            <a:off x="0" y="0"/>
+            <a:off x="0" y="-5862"/>
             <a:ext cx="12191695" cy="6858000"/>
           </a:xfrm>
           <a:prstGeom prst="rect">
@@ -3793,6 +3814,7 @@
           <a:lstStyle/>
           <a:p>
             <a:pPr algn="ctr"/>
+            <a:endParaRPr dirty="0"/>
           </a:p>
         </p:txBody>
       </p:sp>
@@ -3874,9 +3896,160 @@
           </a:p>
         </p:txBody>
       </p:sp>
+      <p:sp>
+        <p:nvSpPr>
+          <p:cNvPr id="6" name="TextBox 5"/>
+          <p:cNvSpPr txBox="1"/>
+          <p:nvPr/>
+        </p:nvSpPr>
+        <p:spPr>
+          <a:xfrm>
+            <a:off x="7955279" y="1920240"/>
+            <a:ext cx="3474720" cy="4114800"/>
+          </a:xfrm>
+          <a:prstGeom prst="rect">
+            <a:avLst/>
+          </a:prstGeom>
+          <a:noFill/>
+        </p:spPr>
+        <p:txBody>
+          <a:bodyPr wrap="square">
+            <a:spAutoFit/>
+          </a:bodyPr>
+          <a:lstStyle/>
+          <a:p>
+            <a:pPr algn="l">
+              <a:lnSpc>
+                <a:spcPct val="125000"/>
+              </a:lnSpc>
+            </a:pPr>
+            <a:r>
+              <a:rPr sz="2400" b="1">
+                <a:solidFill>
+                  <a:srgbClr val="111827"/>
+                </a:solidFill>
+                <a:latin typeface="Arial"/>
+              </a:rPr>
+              <a:t>46 complaints</a:t>
+            </a:r>
+          </a:p>
+          <a:p>
+            <a:pPr algn="l">
+              <a:lnSpc>
+                <a:spcPct val="125000"/>
+              </a:lnSpc>
+            </a:pPr>
+            <a:r>
+              <a:rPr sz="1500" b="0">
+                <a:solidFill>
+                  <a:srgbClr val="6B7280"/>
+                </a:solidFill>
+                <a:latin typeface="Arial"/>
+              </a:rPr>
+              <a:t>39 open · 7 escalated</a:t>
+            </a:r>
+          </a:p>
+          <a:p>
+            <a:pPr algn="l">
+              <a:lnSpc>
+                <a:spcPct val="125000"/>
+              </a:lnSpc>
+            </a:pPr>
+            <a:endParaRPr sz="1500" b="0">
+              <a:solidFill>
+                <a:srgbClr val="6B7280"/>
+              </a:solidFill>
+              <a:latin typeface="Arial"/>
+            </a:endParaRPr>
+          </a:p>
+          <a:p>
+            <a:pPr algn="l">
+              <a:lnSpc>
+                <a:spcPct val="125000"/>
+              </a:lnSpc>
+            </a:pPr>
+            <a:r>
+              <a:rPr sz="1500" b="1">
+                <a:solidFill>
+                  <a:srgbClr val="4F46E5"/>
+                </a:solidFill>
+                <a:latin typeface="Arial"/>
+              </a:rPr>
+              <a:t>priority = reports × severity</a:t>
+            </a:r>
+          </a:p>
+          <a:p>
+            <a:pPr algn="l">
+              <a:lnSpc>
+                <a:spcPct val="125000"/>
+              </a:lnSpc>
+            </a:pPr>
+            <a:r>
+              <a:rPr sz="1400" b="0">
+                <a:solidFill>
+                  <a:srgbClr val="6B7280"/>
+                </a:solidFill>
+                <a:latin typeface="Arial"/>
+              </a:rPr>
+              <a:t>Computed in code, never by the model. An issue escalates at 5 reports, or instantly if it is a safety risk.</a:t>
+            </a:r>
+          </a:p>
+          <a:p>
+            <a:pPr algn="l">
+              <a:lnSpc>
+                <a:spcPct val="125000"/>
+              </a:lnSpc>
+            </a:pPr>
+            <a:endParaRPr sz="1400" b="0">
+              <a:solidFill>
+                <a:srgbClr val="6B7280"/>
+              </a:solidFill>
+              <a:latin typeface="Arial"/>
+            </a:endParaRPr>
+          </a:p>
+          <a:p>
+            <a:pPr algn="l">
+              <a:lnSpc>
+                <a:spcPct val="125000"/>
+              </a:lnSpc>
+            </a:pPr>
+            <a:r>
+              <a:rPr sz="1500" b="1">
+                <a:solidFill>
+                  <a:srgbClr val="4F46E5"/>
+                </a:solidFill>
+                <a:latin typeface="Arial"/>
+              </a:rPr>
+              <a:t>15 buckets</a:t>
+            </a:r>
+          </a:p>
+          <a:p>
+            <a:pPr algn="l">
+              <a:lnSpc>
+                <a:spcPct val="125000"/>
+              </a:lnSpc>
+            </a:pPr>
+            <a:r>
+              <a:rPr sz="1400" b="0">
+                <a:solidFill>
+                  <a:srgbClr val="6B7280"/>
+                </a:solidFill>
+                <a:latin typeface="Arial"/>
+              </a:rPr>
+              <a:t>Each authority — Hostel Office, Mess Committee, IT Cell — sees only its own queue.</a:t>
+            </a:r>
+          </a:p>
+        </p:txBody>
+      </p:sp>
       <p:pic>
         <p:nvPicPr>
-          <p:cNvPr id="5" name="Picture 4" descr="screenshot.png"/>
+          <p:cNvPr id="10" name="Picture 9">
+            <a:extLst>
+              <a:ext uri="{FF2B5EF4-FFF2-40B4-BE49-F238E27FC236}">
+                <a16:creationId xmlns:a16="http://schemas.microsoft.com/office/drawing/2014/main" id="{9134C842-9589-D39B-3CDB-01DB1A5A90C8}"/>
+              </a:ext>
+            </a:extLst>
+          </p:cNvPr>
           <p:cNvPicPr>
             <a:picLocks noChangeAspect="1"/>
           </p:cNvPicPr>
@@ -3890,165 +4063,14 @@
         </p:blipFill>
         <p:spPr>
           <a:xfrm>
-            <a:off x="822960" y="1828800"/>
-            <a:ext cx="6766560" cy="8458200"/>
+            <a:off x="645942" y="1920240"/>
+            <a:ext cx="7181560" cy="3965918"/>
           </a:xfrm>
           <a:prstGeom prst="rect">
             <a:avLst/>
           </a:prstGeom>
         </p:spPr>
       </p:pic>
-      <p:sp>
-        <p:nvSpPr>
-          <p:cNvPr id="6" name="TextBox 5"/>
-          <p:cNvSpPr txBox="1"/>
-          <p:nvPr/>
-        </p:nvSpPr>
-        <p:spPr>
-          <a:xfrm>
-            <a:off x="7955279" y="1920240"/>
-            <a:ext cx="3474720" cy="4114800"/>
-          </a:xfrm>
-          <a:prstGeom prst="rect">
-            <a:avLst/>
-          </a:prstGeom>
-          <a:noFill/>
-        </p:spPr>
-        <p:txBody>
-          <a:bodyPr wrap="square">
-            <a:spAutoFit/>
-          </a:bodyPr>
-          <a:lstStyle/>
-          <a:p>
-            <a:pPr algn="l">
-              <a:lnSpc>
-                <a:spcPct val="125000"/>
-              </a:lnSpc>
-            </a:pPr>
-            <a:r>
-              <a:rPr sz="2400" b="1">
-                <a:solidFill>
-                  <a:srgbClr val="111827"/>
-                </a:solidFill>
-                <a:latin typeface="Arial"/>
-              </a:rPr>
-              <a:t>46 complaints</a:t>
-            </a:r>
-          </a:p>
-          <a:p>
-            <a:pPr algn="l">
-              <a:lnSpc>
-                <a:spcPct val="125000"/>
-              </a:lnSpc>
-            </a:pPr>
-            <a:r>
-              <a:rPr sz="1500" b="0">
-                <a:solidFill>
-                  <a:srgbClr val="6B7280"/>
-                </a:solidFill>
-                <a:latin typeface="Arial"/>
-              </a:rPr>
-              <a:t>39 open · 7 escalated</a:t>
-            </a:r>
-          </a:p>
-          <a:p>
-            <a:pPr algn="l">
-              <a:lnSpc>
-                <a:spcPct val="125000"/>
-              </a:lnSpc>
-            </a:pPr>
-            <a:r>
-              <a:rPr sz="800" b="0">
-                <a:solidFill>
-                  <a:srgbClr val="6B7280"/>
-                </a:solidFill>
-                <a:latin typeface="Arial"/>
-              </a:rPr>
-              <a:t/>
-            </a:r>
-          </a:p>
-          <a:p>
-            <a:pPr algn="l">
-              <a:lnSpc>
-                <a:spcPct val="125000"/>
-              </a:lnSpc>
-            </a:pPr>
-            <a:r>
-              <a:rPr sz="1500" b="1">
-                <a:solidFill>
-                  <a:srgbClr val="4F46E5"/>
-                </a:solidFill>
-                <a:latin typeface="Arial"/>
-              </a:rPr>
-              <a:t>priority = reports × severity</a:t>
-            </a:r>
-          </a:p>
-          <a:p>
-            <a:pPr algn="l">
-              <a:lnSpc>
-                <a:spcPct val="125000"/>
-              </a:lnSpc>
-            </a:pPr>
-            <a:r>
-              <a:rPr sz="1400" b="0">
-                <a:solidFill>
-                  <a:srgbClr val="6B7280"/>
-                </a:solidFill>
-                <a:latin typeface="Arial"/>
-              </a:rPr>
-              <a:t>Computed in code, never by the model. An issue escalates at 5 reports, or instantly if it is a safety risk.</a:t>
-            </a:r>
-          </a:p>
-          <a:p>
-            <a:pPr algn="l">
-              <a:lnSpc>
-                <a:spcPct val="125000"/>
-              </a:lnSpc>
-            </a:pPr>
-            <a:r>
-              <a:rPr sz="800" b="0">
-                <a:solidFill>
-                  <a:srgbClr val="6B7280"/>
-                </a:solidFill>
-                <a:latin typeface="Arial"/>
-              </a:rPr>
-              <a:t/>
-            </a:r>
-          </a:p>
-          <a:p>
-            <a:pPr algn="l">
-              <a:lnSpc>
-                <a:spcPct val="125000"/>
-              </a:lnSpc>
-            </a:pPr>
-            <a:r>
-              <a:rPr sz="1500" b="1">
-                <a:solidFill>
-                  <a:srgbClr val="4F46E5"/>
-                </a:solidFill>
-                <a:latin typeface="Arial"/>
-              </a:rPr>
-              <a:t>15 buckets</a:t>
-            </a:r>
-          </a:p>
-          <a:p>
-            <a:pPr algn="l">
-              <a:lnSpc>
-                <a:spcPct val="125000"/>
-              </a:lnSpc>
-            </a:pPr>
-            <a:r>
-              <a:rPr sz="1400" b="0">
-                <a:solidFill>
-                  <a:srgbClr val="6B7280"/>
-                </a:solidFill>
-                <a:latin typeface="Arial"/>
-              </a:rPr>
-              <a:t>Each authority — Hostel Office, Mess Committee, IT Cell — sees only its own queue.</a:t>
-            </a:r>
-          </a:p>
-        </p:txBody>
-      </p:sp>
     </p:spTree>
   </p:cSld>
   <p:clrMapOvr>
@@ -4058,7 +4080,7 @@
 </file>
 
 <file path=ppt/slides/slide4.xml><?xml version="1.0" encoding="utf-8"?>
-<p:sld xmlns:a="http://schemas.openxmlformats.org/drawingml/2006/main" xmlns:p="http://schemas.openxmlformats.org/presentationml/2006/main" xmlns:r="http://schemas.openxmlformats.org/officeDocument/2006/relationships">
+<p:sld xmlns:a="http://schemas.openxmlformats.org/drawingml/2006/main" xmlns:r="http://schemas.openxmlformats.org/officeDocument/2006/relationships" xmlns:p="http://schemas.openxmlformats.org/presentationml/2006/main">
   <p:cSld>
     <p:spTree>
       <p:nvGrpSpPr>
@@ -4066,7 +4088,14 @@
         <p:cNvGrpSpPr/>
         <p:nvPr/>
       </p:nvGrpSpPr>
-      <p:grpSpPr/>
+      <p:grpSpPr>
+        <a:xfrm>
+          <a:off x="0" y="0"/>
+          <a:ext cx="0" cy="0"/>
+          <a:chOff x="0" y="0"/>
+          <a:chExt cx="0" cy="0"/>
+        </a:xfrm>
+      </p:grpSpPr>
       <p:sp>
         <p:nvSpPr>
           <p:cNvPr id="2" name="Rectangle 1"/>
@@ -4108,6 +4137,7 @@
           <a:lstStyle/>
           <a:p>
             <a:pPr algn="ctr"/>
+            <a:endParaRPr/>
           </a:p>
         </p:txBody>
       </p:sp>
@@ -4230,6 +4260,7 @@
           <a:lstStyle/>
           <a:p>
             <a:pPr algn="ctr"/>
+            <a:endParaRPr/>
           </a:p>
         </p:txBody>
       </p:sp>
@@ -4315,6 +4346,7 @@
           <a:lstStyle/>
           <a:p>
             <a:pPr algn="ctr"/>
+            <a:endParaRPr/>
           </a:p>
         </p:txBody>
       </p:sp>
@@ -4377,14 +4409,27 @@
                 <a:spcPct val="120000"/>
               </a:lnSpc>
             </a:pPr>
-            <a:r>
-              <a:rPr sz="700" b="0">
-                <a:solidFill>
-                  <a:srgbClr val="6B7280"/>
+            <a:endParaRPr sz="1700" b="0">
+              <a:solidFill>
+                <a:srgbClr val="111827"/>
+              </a:solidFill>
+              <a:latin typeface="Arial"/>
+            </a:endParaRPr>
+          </a:p>
+          <a:p>
+            <a:pPr algn="l">
+              <a:lnSpc>
+                <a:spcPct val="120000"/>
+              </a:lnSpc>
+            </a:pPr>
+            <a:r>
+              <a:rPr sz="1100" b="1">
+                <a:solidFill>
+                  <a:srgbClr val="4F46E5"/>
                 </a:solidFill>
                 <a:latin typeface="Arial"/>
               </a:rPr>
-              <a:t/>
+              <a:t>Gemma</a:t>
             </a:r>
           </a:p>
           <a:p>
@@ -4394,13 +4439,13 @@
               </a:lnSpc>
             </a:pPr>
             <a:r>
-              <a:rPr sz="1100" b="1">
+              <a:rPr sz="1700" b="0">
                 <a:solidFill>
                   <a:srgbClr val="4F46E5"/>
                 </a:solidFill>
                 <a:latin typeface="Arial"/>
               </a:rPr>
-              <a:t>Gemma</a:t>
+              <a:t>Kaunse hostel aur kis room mein AC se paani tapak raha hai?</a:t>
             </a:r>
           </a:p>
           <a:p>
@@ -4409,31 +4454,12 @@
                 <a:spcPct val="120000"/>
               </a:lnSpc>
             </a:pPr>
-            <a:r>
-              <a:rPr sz="1700" b="0">
-                <a:solidFill>
-                  <a:srgbClr val="4F46E5"/>
-                </a:solidFill>
-                <a:latin typeface="Arial"/>
-              </a:rPr>
-              <a:t>Kaunse hostel aur kis room mein AC se paani tapak raha hai?</a:t>
-            </a:r>
-          </a:p>
-          <a:p>
-            <a:pPr algn="l">
-              <a:lnSpc>
-                <a:spcPct val="120000"/>
-              </a:lnSpc>
-            </a:pPr>
-            <a:r>
-              <a:rPr sz="700" b="0">
-                <a:solidFill>
-                  <a:srgbClr val="6B7280"/>
-                </a:solidFill>
-                <a:latin typeface="Arial"/>
-              </a:rPr>
-              <a:t/>
-            </a:r>
+            <a:endParaRPr sz="1700" b="0">
+              <a:solidFill>
+                <a:srgbClr val="4F46E5"/>
+              </a:solidFill>
+              <a:latin typeface="Arial"/>
+            </a:endParaRPr>
           </a:p>
           <a:p>
             <a:pPr algn="l">
@@ -4528,15 +4554,12 @@
                 <a:spcPct val="125000"/>
               </a:lnSpc>
             </a:pPr>
-            <a:r>
-              <a:rPr sz="900" b="0">
-                <a:solidFill>
-                  <a:srgbClr val="6B7280"/>
-                </a:solidFill>
-                <a:latin typeface="Arial"/>
-              </a:rPr>
-              <a:t/>
-            </a:r>
+            <a:endParaRPr sz="1500" b="0">
+              <a:solidFill>
+                <a:srgbClr val="6B7280"/>
+              </a:solidFill>
+              <a:latin typeface="Arial"/>
+            </a:endParaRPr>
           </a:p>
           <a:p>
             <a:pPr algn="l">
@@ -4615,6 +4638,7 @@
           <a:lstStyle/>
           <a:p>
             <a:pPr algn="ctr"/>
+            <a:endParaRPr/>
           </a:p>
         </p:txBody>
       </p:sp>
@@ -4666,7 +4690,7 @@
 </file>
 
 <file path=ppt/slides/slide5.xml><?xml version="1.0" encoding="utf-8"?>
-<p:sld xmlns:a="http://schemas.openxmlformats.org/drawingml/2006/main" xmlns:p="http://schemas.openxmlformats.org/presentationml/2006/main" xmlns:r="http://schemas.openxmlformats.org/officeDocument/2006/relationships">
+<p:sld xmlns:a="http://schemas.openxmlformats.org/drawingml/2006/main" xmlns:r="http://schemas.openxmlformats.org/officeDocument/2006/relationships" xmlns:p="http://schemas.openxmlformats.org/presentationml/2006/main">
   <p:cSld>
     <p:spTree>
       <p:nvGrpSpPr>
@@ -4674,7 +4698,14 @@
         <p:cNvGrpSpPr/>
         <p:nvPr/>
       </p:nvGrpSpPr>
-      <p:grpSpPr/>
+      <p:grpSpPr>
+        <a:xfrm>
+          <a:off x="0" y="0"/>
+          <a:ext cx="0" cy="0"/>
+          <a:chOff x="0" y="0"/>
+          <a:chExt cx="0" cy="0"/>
+        </a:xfrm>
+      </p:grpSpPr>
       <p:sp>
         <p:nvSpPr>
           <p:cNvPr id="2" name="Rectangle 1"/>
@@ -4716,6 +4747,7 @@
           <a:lstStyle/>
           <a:p>
             <a:pPr algn="ctr"/>
+            <a:endParaRPr/>
           </a:p>
         </p:txBody>
       </p:sp>
@@ -4838,6 +4870,7 @@
           <a:lstStyle/>
           <a:p>
             <a:pPr algn="ctr"/>
+            <a:endParaRPr/>
           </a:p>
         </p:txBody>
       </p:sp>
@@ -4900,15 +4933,12 @@
                 <a:spcPct val="125000"/>
               </a:lnSpc>
             </a:pPr>
-            <a:r>
-              <a:rPr sz="1000" b="0">
-                <a:solidFill>
-                  <a:srgbClr val="6B7280"/>
-                </a:solidFill>
-                <a:latin typeface="Arial"/>
-              </a:rPr>
-              <a:t/>
-            </a:r>
+            <a:endParaRPr sz="1500" b="0">
+              <a:solidFill>
+                <a:srgbClr val="6B7280"/>
+              </a:solidFill>
+              <a:latin typeface="Arial"/>
+            </a:endParaRPr>
           </a:p>
           <a:p>
             <a:pPr algn="l">
@@ -4987,6 +5017,7 @@
           <a:lstStyle/>
           <a:p>
             <a:pPr algn="ctr"/>
+            <a:endParaRPr/>
           </a:p>
         </p:txBody>
       </p:sp>
@@ -5136,15 +5167,12 @@
                 <a:spcPct val="125000"/>
               </a:lnSpc>
             </a:pPr>
-            <a:r>
-              <a:rPr sz="800" b="0">
-                <a:solidFill>
-                  <a:srgbClr val="6B7280"/>
-                </a:solidFill>
-                <a:latin typeface="Arial"/>
-              </a:rPr>
-              <a:t/>
-            </a:r>
+            <a:endParaRPr sz="1500" b="0">
+              <a:solidFill>
+                <a:srgbClr val="6B7280"/>
+              </a:solidFill>
+              <a:latin typeface="Arial"/>
+            </a:endParaRPr>
           </a:p>
           <a:p>
             <a:pPr algn="l">
@@ -5173,7 +5201,7 @@
 </file>
 
 <file path=ppt/slides/slide6.xml><?xml version="1.0" encoding="utf-8"?>
-<p:sld xmlns:a="http://schemas.openxmlformats.org/drawingml/2006/main" xmlns:p="http://schemas.openxmlformats.org/presentationml/2006/main" xmlns:r="http://schemas.openxmlformats.org/officeDocument/2006/relationships">
+<p:sld xmlns:a="http://schemas.openxmlformats.org/drawingml/2006/main" xmlns:r="http://schemas.openxmlformats.org/officeDocument/2006/relationships" xmlns:p="http://schemas.openxmlformats.org/presentationml/2006/main">
   <p:cSld>
     <p:spTree>
       <p:nvGrpSpPr>
@@ -5181,7 +5209,14 @@
         <p:cNvGrpSpPr/>
         <p:nvPr/>
       </p:nvGrpSpPr>
-      <p:grpSpPr/>
+      <p:grpSpPr>
+        <a:xfrm>
+          <a:off x="0" y="0"/>
+          <a:ext cx="0" cy="0"/>
+          <a:chOff x="0" y="0"/>
+          <a:chExt cx="0" cy="0"/>
+        </a:xfrm>
+      </p:grpSpPr>
       <p:sp>
         <p:nvSpPr>
           <p:cNvPr id="2" name="Rectangle 1"/>
@@ -5223,6 +5258,7 @@
           <a:lstStyle/>
           <a:p>
             <a:pPr algn="ctr"/>
+            <a:endParaRPr/>
           </a:p>
         </p:txBody>
       </p:sp>
@@ -5345,6 +5381,7 @@
           <a:lstStyle/>
           <a:p>
             <a:pPr algn="ctr"/>
+            <a:endParaRPr/>
           </a:p>
         </p:txBody>
       </p:sp>
@@ -5389,6 +5426,7 @@
           <a:lstStyle/>
           <a:p>
             <a:pPr algn="ctr"/>
+            <a:endParaRPr/>
           </a:p>
         </p:txBody>
       </p:sp>
@@ -5511,6 +5549,7 @@
           <a:lstStyle/>
           <a:p>
             <a:pPr algn="ctr"/>
+            <a:endParaRPr/>
           </a:p>
         </p:txBody>
       </p:sp>
@@ -5633,6 +5672,7 @@
           <a:lstStyle/>
           <a:p>
             <a:pPr algn="ctr"/>
+            <a:endParaRPr/>
           </a:p>
         </p:txBody>
       </p:sp>
@@ -5755,6 +5795,7 @@
           <a:lstStyle/>
           <a:p>
             <a:pPr algn="ctr"/>
+            <a:endParaRPr/>
           </a:p>
         </p:txBody>
       </p:sp>
@@ -5877,6 +5918,7 @@
           <a:lstStyle/>
           <a:p>
             <a:pPr algn="ctr"/>
+            <a:endParaRPr/>
           </a:p>
         </p:txBody>
       </p:sp>
@@ -6001,6 +6043,7 @@
           <a:lstStyle/>
           <a:p>
             <a:pPr algn="ctr"/>
+            <a:endParaRPr/>
           </a:p>
         </p:txBody>
       </p:sp>
@@ -6052,7 +6095,7 @@
 </file>
 
 <file path=ppt/slides/slide7.xml><?xml version="1.0" encoding="utf-8"?>
-<p:sld xmlns:a="http://schemas.openxmlformats.org/drawingml/2006/main" xmlns:p="http://schemas.openxmlformats.org/presentationml/2006/main" xmlns:r="http://schemas.openxmlformats.org/officeDocument/2006/relationships">
+<p:sld xmlns:a="http://schemas.openxmlformats.org/drawingml/2006/main" xmlns:r="http://schemas.openxmlformats.org/officeDocument/2006/relationships" xmlns:p="http://schemas.openxmlformats.org/presentationml/2006/main">
   <p:cSld>
     <p:spTree>
       <p:nvGrpSpPr>
@@ -6060,7 +6103,14 @@
         <p:cNvGrpSpPr/>
         <p:nvPr/>
       </p:nvGrpSpPr>
-      <p:grpSpPr/>
+      <p:grpSpPr>
+        <a:xfrm>
+          <a:off x="0" y="0"/>
+          <a:ext cx="0" cy="0"/>
+          <a:chOff x="0" y="0"/>
+          <a:chExt cx="0" cy="0"/>
+        </a:xfrm>
+      </p:grpSpPr>
       <p:sp>
         <p:nvSpPr>
           <p:cNvPr id="2" name="Rectangle 1"/>
@@ -6102,6 +6152,7 @@
           <a:lstStyle/>
           <a:p>
             <a:pPr algn="ctr"/>
+            <a:endParaRPr/>
           </a:p>
         </p:txBody>
       </p:sp>
@@ -6224,6 +6275,7 @@
           <a:lstStyle/>
           <a:p>
             <a:pPr algn="ctr"/>
+            <a:endParaRPr/>
           </a:p>
         </p:txBody>
       </p:sp>

</xml_diff>